<commit_message>
docs: ajustar contexto de aplicación a Sucre e integrar captura activa de inferencia con placa 1026PKF
</commit_message>
<xml_diff>
--- a/docs/PRESENTACION_PROYECTO.pptx
+++ b/docs/PRESENTACION_PROYECTO.pptx
@@ -3252,7 +3252,7 @@
               </a:defRPr>
             </a:pPr>
             <a:r>
-              <a:t>Arquitectura YOLO26 + Motor OCR Híbrido (PaddleOCR / OpenCV) | Santa Cruz de la Sierra</a:t>
+              <a:t>Arquitectura YOLO26 + Motor OCR Híbrido (PaddleOCR / OpenCV) | Sucre, Bolivia</a:t>
             </a:r>
           </a:p>
         </p:txBody>
@@ -4682,7 +4682,7 @@
               </a:defRPr>
             </a:pPr>
             <a:r>
-              <a:t>Desafíos en Santa Cruz de la Sierra</a:t>
+              <a:t>Desafíos en la Ciudad de Sucre</a:t>
             </a:r>
           </a:p>
         </p:txBody>
@@ -4769,7 +4769,7 @@
               </a:defRPr>
             </a:pPr>
             <a:r>
-              <a:t>• Entorno Urbano Ruidoso: </a:t>
+              <a:t>• Entorno Urbano Complejo: </a:t>
             </a:r>
             <a:r>
               <a:rPr b="0">
@@ -4777,7 +4777,7 @@
                   <a:srgbClr val="94A3B8"/>
                 </a:solidFill>
               </a:rPr>
-              <a:t>Letreros de rutas, publicidad en parabrisas y tráfico denso inducen falsos positivos en sistemas OCR convencionales.</a:t>
+              <a:t>Letreros de rutas, publicidad en parabrisas y calles estrechas con tráfico denso dificultan la lectura manual.</a:t>
             </a:r>
           </a:p>
         </p:txBody>
@@ -7881,7 +7881,7 @@
       </p:sp>
       <p:pic>
         <p:nvPicPr>
-          <p:cNvPr id="5" name="Picture 4" descr="01_dashboard_inferencia.png"/>
+          <p:cNvPr id="5" name="Picture 4" descr="01_dashboard_inferencia_activa.png"/>
           <p:cNvPicPr>
             <a:picLocks noChangeAspect="1"/>
           </p:cNvPicPr>

</xml_diff>